<commit_message>
Week 05: small wording fixes in the lecture slides and the Q3 notebook
- Lecture .pptx: slide 2 "Review – MILP"; slide 5 "e.g."; slide 18 single
  space in "City 1, City 2 and City 6" (text only).
- Q3 Icki-Toffee notebook: "Variety costs 42" (Table 3 gives cost without a
  currency); text only, code and outputs unchanged.

Co-Authored-By: Claude Opus 5.5 <noreply@anthropic.com>
Claude-Session: https://claude.ai/code/session_01Ft9Pd2swN5w6FfG6UvEk1q

[skip ci]
</commit_message>
<xml_diff>
--- a/content/Lectures/Semester 1/Week 05 - Mixed Integer Programming/1 Lecture/Week 5 - Mixed Integer Programming.pptx
+++ b/content/Lectures/Semester 1/Week 05 - Mixed Integer Programming/1 Lecture/Week 5 - Mixed Integer Programming.pptx
@@ -13655,7 +13655,7 @@
               <a:p>
                 <a:r>
                   <a:rPr lang="en-GB" sz="2400" dirty="0"/>
-                  <a:t>City 1, City 2  and City 6</a:t>
+                  <a:t>City 1, City 2 and City 6</a:t>
                 </a:r>
               </a:p>
               <a:p>
@@ -16533,7 +16533,7 @@
           <a:p>
             <a:r>
               <a:rPr lang="en-GB" dirty="0"/>
-              <a:t>Review –MILP</a:t>
+              <a:t>Review – MILP</a:t>
             </a:r>
           </a:p>
           <a:p>
@@ -32932,8 +32932,8 @@
               <a:buNone/>
             </a:pPr>
             <a:r>
-              <a:rPr lang="en-GB" dirty="0" err="1"/>
-              <a:t>e.g</a:t>
+              <a:rPr lang="en-GB" dirty="0"/>
+              <a:t>e.g.</a:t>
             </a:r>
             <a:endParaRPr lang="en-GB" dirty="0"/>
           </a:p>

</xml_diff>